<commit_message>
docs/presentation-script.md: slide-by-slide reading script; deck no longer mentions the allow-list
The script is generated from the deck's speaker notes, with a pre-demo checklist, real vs simulated,
running order and a fallback table. Slide 23 and two notes now say the SMS is simulated and the
WhatsApp alerts are real.

Co-Authored-By: Claude Opus 5.5 <noreply@anthropic.com>
</commit_message>
<xml_diff>
--- a/docs/presentation/MzansiRide_SafeAI_Deck.pptx
+++ b/docs/presentation/MzansiRide_SafeAI_Deck.pptx
@@ -1390,7 +1390,7 @@
           <a:p>
             <a:r>
               <a:rPr lang="en-US" dirty="0"/>
-              <a:t>“Once the trip starts, Safe Journey Mode is on and watching for unusual stops and route changes. The passenger can see her trusted contact, share her trip, or send an SOS in one tap. The page says plainly that notifications are simulated unless the number is on our demo allow-list, so nothing here is hidden.”</a:t>
+              <a:t>“Once the trip starts, Safe Journey Mode is on and watching for unusual stops and route changes. The passenger can see her trusted contact, share her trip, or send an SOS in one tap. The page says plainly what is real and what is simulated: WhatsApp alerts to the trusted contact are real, and the SMS is labelled simulated, so nothing here is hidden.”</a:t>
             </a:r>
             <a:endParaRPr lang="en-US" dirty="0"/>
           </a:p>
@@ -2149,7 +2149,7 @@
           <a:p>
             <a:r>
               <a:rPr lang="en-US" dirty="0"/>
-              <a:t>“Here’s an honest view of where we are. Working today: ride request with the fare comparison and a monthly budget; Safe Journey Mode with trusted contact, share trip and SOS; proactive WhatsApp check-ins on a real number, answered with 1, 2 or in your own words; the no-reply workflow with an operator-set wait window; the fleet dashboard with AI triage; the Amazon Bedrock assistant; and the safety log in DynamoDB. Simulated: trips and route events, driver profiles and the Face ID result, and notifications unless the number is on the demo allow-list. Still to come: live GPS, real driver verification, emergency-service integration, real payments, and a POPIA assessment with an operator pilot. We do not claim to prevent crime, guarantee safety or verify drivers.”</a:t>
+              <a:t>“Here’s an honest view of where we are. Working today: ride request with the fare comparison and a monthly budget; Safe Journey Mode with trusted contact, share trip and SOS; proactive WhatsApp check-ins on a real number, answered with 1, 2 or in your own words; the no-reply workflow with an operator-set wait window; the fleet dashboard with AI triage; the Amazon Bedrock assistant; and the safety log in DynamoDB. Simulated: trips and route events, driver profiles and the Face ID result, and the SMS to the trusted contact. The WhatsApp alerts are real. Still to come: live GPS, real driver verification, emergency-service integration, real payments, and a POPIA assessment with an operator pilot. We do not claim to prevent crime, guarantee safety or verify drivers.”</a:t>
             </a:r>
             <a:endParaRPr lang="en-US" dirty="0"/>
           </a:p>
@@ -11559,7 +11559,7 @@
                   <a:schemeClr val="tx1"/>
                 </a:solidFill>
               </a:rPr>
-              <a:t>Notifications, unless the number is on the demo allow-list</a:t>
+              <a:t>The SMS to the trusted contact (WhatsApp alerts are real)</a:t>
             </a:r>
             <a:endParaRPr lang="en-US" sz="1200" dirty="0"/>
           </a:p>

</xml_diff>